<commit_message>
Update Week 7. Modeling_Ecological_Niches.pptx
</commit_message>
<xml_diff>
--- a/Slides/Week 7. Modeling_Ecological_Niches.pptx
+++ b/Slides/Week 7. Modeling_Ecological_Niches.pptx
@@ -5,10 +5,10 @@
     <p:sldMasterId id="2147483648" r:id="rId1"/>
   </p:sldMasterIdLst>
   <p:notesMasterIdLst>
-    <p:notesMasterId r:id="rId30"/>
+    <p:notesMasterId r:id="rId31"/>
   </p:notesMasterIdLst>
   <p:handoutMasterIdLst>
-    <p:handoutMasterId r:id="rId31"/>
+    <p:handoutMasterId r:id="rId32"/>
   </p:handoutMasterIdLst>
   <p:sldIdLst>
     <p:sldId id="256" r:id="rId2"/>
@@ -39,6 +39,7 @@
     <p:sldId id="652" r:id="rId27"/>
     <p:sldId id="661" r:id="rId28"/>
     <p:sldId id="653" r:id="rId29"/>
+    <p:sldId id="662" r:id="rId30"/>
   </p:sldIdLst>
   <p:sldSz cx="9144000" cy="5143500" type="screen16x9"/>
   <p:notesSz cx="6858000" cy="9144000"/>
@@ -170,6 +171,7 @@
             <p14:sldId id="652"/>
             <p14:sldId id="661"/>
             <p14:sldId id="653"/>
+            <p14:sldId id="662"/>
           </p14:sldIdLst>
         </p14:section>
       </p14:sectionLst>
@@ -295,7 +297,7 @@
           <a:p>
             <a:fld id="{5D8404FB-D815-9B49-9DBC-B684E3C0E790}" type="datetimeFigureOut">
               <a:rPr lang="en-US" smtClean="0"/>
-              <a:t>10/6/26</a:t>
+              <a:t>10/8/26</a:t>
             </a:fld>
             <a:endParaRPr lang="en-US"/>
           </a:p>
@@ -472,7 +474,7 @@
           <a:p>
             <a:fld id="{18AC5A93-540D-2443-A380-5679C155FF14}" type="datetimeFigureOut">
               <a:rPr lang="en-US" smtClean="0"/>
-              <a:t>10/6/26</a:t>
+              <a:t>10/8/26</a:t>
             </a:fld>
             <a:endParaRPr lang="en-US"/>
           </a:p>
@@ -1052,7 +1054,7 @@
           <a:p>
             <a:fld id="{D19067CA-FF63-4940-92DF-E3096929B04A}" type="datetimeFigureOut">
               <a:rPr lang="en-US" smtClean="0"/>
-              <a:t>10/6/26</a:t>
+              <a:t>10/8/26</a:t>
             </a:fld>
             <a:endParaRPr lang="en-US"/>
           </a:p>
@@ -1246,7 +1248,7 @@
           <a:p>
             <a:fld id="{D19067CA-FF63-4940-92DF-E3096929B04A}" type="datetimeFigureOut">
               <a:rPr lang="en-US" smtClean="0"/>
-              <a:t>10/6/26</a:t>
+              <a:t>10/8/26</a:t>
             </a:fld>
             <a:endParaRPr lang="en-US"/>
           </a:p>
@@ -1430,7 +1432,7 @@
           <a:p>
             <a:fld id="{D19067CA-FF63-4940-92DF-E3096929B04A}" type="datetimeFigureOut">
               <a:rPr lang="en-US" smtClean="0"/>
-              <a:t>10/6/26</a:t>
+              <a:t>10/8/26</a:t>
             </a:fld>
             <a:endParaRPr lang="en-US"/>
           </a:p>
@@ -1691,7 +1693,7 @@
           <a:p>
             <a:fld id="{D19067CA-FF63-4940-92DF-E3096929B04A}" type="datetimeFigureOut">
               <a:rPr lang="en-US" smtClean="0"/>
-              <a:t>10/6/26</a:t>
+              <a:t>10/8/26</a:t>
             </a:fld>
             <a:endParaRPr lang="en-US"/>
           </a:p>
@@ -1992,7 +1994,7 @@
           <a:p>
             <a:fld id="{D19067CA-FF63-4940-92DF-E3096929B04A}" type="datetimeFigureOut">
               <a:rPr lang="en-US" smtClean="0"/>
-              <a:t>10/6/26</a:t>
+              <a:t>10/8/26</a:t>
             </a:fld>
             <a:endParaRPr lang="en-US"/>
           </a:p>
@@ -2427,7 +2429,7 @@
           <a:p>
             <a:fld id="{D19067CA-FF63-4940-92DF-E3096929B04A}" type="datetimeFigureOut">
               <a:rPr lang="en-US" smtClean="0"/>
-              <a:t>10/6/26</a:t>
+              <a:t>10/8/26</a:t>
             </a:fld>
             <a:endParaRPr lang="en-US"/>
           </a:p>
@@ -2560,7 +2562,7 @@
           <a:p>
             <a:fld id="{D19067CA-FF63-4940-92DF-E3096929B04A}" type="datetimeFigureOut">
               <a:rPr lang="en-US" smtClean="0"/>
-              <a:t>10/6/26</a:t>
+              <a:t>10/8/26</a:t>
             </a:fld>
             <a:endParaRPr lang="en-US"/>
           </a:p>
@@ -2671,7 +2673,7 @@
           <a:p>
             <a:fld id="{D19067CA-FF63-4940-92DF-E3096929B04A}" type="datetimeFigureOut">
               <a:rPr lang="en-US" smtClean="0"/>
-              <a:t>10/6/26</a:t>
+              <a:t>10/8/26</a:t>
             </a:fld>
             <a:endParaRPr lang="en-US"/>
           </a:p>
@@ -2962,7 +2964,7 @@
           <a:p>
             <a:fld id="{D19067CA-FF63-4940-92DF-E3096929B04A}" type="datetimeFigureOut">
               <a:rPr lang="en-US" smtClean="0"/>
-              <a:t>10/6/26</a:t>
+              <a:t>10/8/26</a:t>
             </a:fld>
             <a:endParaRPr lang="en-US"/>
           </a:p>
@@ -3230,7 +3232,7 @@
           <a:p>
             <a:fld id="{D19067CA-FF63-4940-92DF-E3096929B04A}" type="datetimeFigureOut">
               <a:rPr lang="en-US" smtClean="0"/>
-              <a:t>10/6/26</a:t>
+              <a:t>10/8/26</a:t>
             </a:fld>
             <a:endParaRPr lang="en-US"/>
           </a:p>
@@ -10138,6 +10140,98 @@
       </p:par>
     </p:tnLst>
   </p:timing>
+</p:sld>
+</file>
+
+<file path=ppt/slides/slide29.xml><?xml version="1.0" encoding="utf-8"?>
+<p:sld xmlns:a="http://schemas.openxmlformats.org/drawingml/2006/main" xmlns:r="http://schemas.openxmlformats.org/officeDocument/2006/relationships" xmlns:p="http://schemas.openxmlformats.org/presentationml/2006/main">
+  <p:cSld>
+    <p:spTree>
+      <p:nvGrpSpPr>
+        <p:cNvPr id="1" name=""/>
+        <p:cNvGrpSpPr/>
+        <p:nvPr/>
+      </p:nvGrpSpPr>
+      <p:grpSpPr>
+        <a:xfrm>
+          <a:off x="0" y="0"/>
+          <a:ext cx="0" cy="0"/>
+          <a:chOff x="0" y="0"/>
+          <a:chExt cx="0" cy="0"/>
+        </a:xfrm>
+      </p:grpSpPr>
+      <p:sp>
+        <p:nvSpPr>
+          <p:cNvPr id="2" name="Title 1">
+            <a:extLst>
+              <a:ext uri="{FF2B5EF4-FFF2-40B4-BE49-F238E27FC236}">
+                <a16:creationId xmlns:a16="http://schemas.microsoft.com/office/drawing/2014/main" id="{C46D9AB7-514C-9A69-0408-3904B851E275}"/>
+              </a:ext>
+            </a:extLst>
+          </p:cNvPr>
+          <p:cNvSpPr>
+            <a:spLocks noGrp="1"/>
+          </p:cNvSpPr>
+          <p:nvPr>
+            <p:ph type="title"/>
+          </p:nvPr>
+        </p:nvSpPr>
+        <p:spPr/>
+        <p:txBody>
+          <a:bodyPr/>
+          <a:lstStyle/>
+          <a:p>
+            <a:r>
+              <a:rPr lang="en-US" dirty="0"/>
+              <a:t>Updates</a:t>
+            </a:r>
+          </a:p>
+        </p:txBody>
+      </p:sp>
+      <p:sp>
+        <p:nvSpPr>
+          <p:cNvPr id="3" name="Content Placeholder 2">
+            <a:extLst>
+              <a:ext uri="{FF2B5EF4-FFF2-40B4-BE49-F238E27FC236}">
+                <a16:creationId xmlns:a16="http://schemas.microsoft.com/office/drawing/2014/main" id="{1748E832-9740-4FD1-A5C1-CB311E65570C}"/>
+              </a:ext>
+            </a:extLst>
+          </p:cNvPr>
+          <p:cNvSpPr>
+            <a:spLocks noGrp="1"/>
+          </p:cNvSpPr>
+          <p:nvPr>
+            <p:ph idx="1"/>
+          </p:nvPr>
+        </p:nvSpPr>
+        <p:spPr/>
+        <p:txBody>
+          <a:bodyPr/>
+          <a:lstStyle/>
+          <a:p>
+            <a:r>
+              <a:rPr lang="en-US" dirty="0"/>
+              <a:t>I uploaded all the term project assignments</a:t>
+            </a:r>
+          </a:p>
+          <a:p>
+            <a:r>
+              <a:rPr lang="en-US" dirty="0"/>
+              <a:t>Read Peterson et al. Chapter 8 by next Tuesday</a:t>
+            </a:r>
+          </a:p>
+        </p:txBody>
+      </p:sp>
+    </p:spTree>
+    <p:extLst>
+      <p:ext uri="{BB962C8B-B14F-4D97-AF65-F5344CB8AC3E}">
+        <p14:creationId xmlns:p14="http://schemas.microsoft.com/office/powerpoint/2010/main" val="1425039257"/>
+      </p:ext>
+    </p:extLst>
+  </p:cSld>
+  <p:clrMapOvr>
+    <a:masterClrMapping/>
+  </p:clrMapOvr>
 </p:sld>
 </file>
 

</xml_diff>